<commit_message>
Update screenshots of code
Code was changed to remove redundant masking
</commit_message>
<xml_diff>
--- a/documentation/for_collaborators/AnalysisOverview.pptx
+++ b/documentation/for_collaborators/AnalysisOverview.pptx
@@ -7709,32 +7709,70 @@
       </p:sp>
       <p:grpSp>
         <p:nvGrpSpPr>
-          <p:cNvPr id="13" name="Group 12">
+          <p:cNvPr id="15" name="Group 14">
             <a:extLst>
               <a:ext uri="{FF2B5EF4-FFF2-40B4-BE49-F238E27FC236}">
-                <a16:creationId xmlns:a16="http://schemas.microsoft.com/office/drawing/2014/main" id="{8741B825-BC4E-C721-6C7A-1CCEA5A930F7}"/>
+                <a16:creationId xmlns:a16="http://schemas.microsoft.com/office/drawing/2014/main" id="{2E75006F-BDC5-B94D-8B39-3E088897142C}"/>
               </a:ext>
             </a:extLst>
           </p:cNvPr>
-          <p:cNvGrpSpPr>
-            <a:grpSpLocks noChangeAspect="1"/>
-          </p:cNvGrpSpPr>
+          <p:cNvGrpSpPr/>
           <p:nvPr/>
         </p:nvGrpSpPr>
         <p:grpSpPr>
           <a:xfrm>
-            <a:off x="1033052" y="2377441"/>
-            <a:ext cx="8014519" cy="3157859"/>
-            <a:chOff x="121909" y="2568286"/>
-            <a:chExt cx="7616115" cy="3000881"/>
+            <a:off x="349858" y="2377441"/>
+            <a:ext cx="9379922" cy="3157858"/>
+            <a:chOff x="-408894" y="2377442"/>
+            <a:chExt cx="9379922" cy="3157858"/>
           </a:xfrm>
         </p:grpSpPr>
+        <p:sp>
+          <p:nvSpPr>
+            <p:cNvPr id="10" name="TextBox 9">
+              <a:extLst>
+                <a:ext uri="{FF2B5EF4-FFF2-40B4-BE49-F238E27FC236}">
+                  <a16:creationId xmlns:a16="http://schemas.microsoft.com/office/drawing/2014/main" id="{951E1D4C-C443-76A6-47F2-F4E497381A31}"/>
+                </a:ext>
+              </a:extLst>
+            </p:cNvPr>
+            <p:cNvSpPr txBox="1"/>
+            <p:nvPr/>
+          </p:nvSpPr>
+          <p:spPr>
+            <a:xfrm>
+              <a:off x="-408894" y="3738022"/>
+              <a:ext cx="1825786" cy="388652"/>
+            </a:xfrm>
+            <a:prstGeom prst="rect">
+              <a:avLst/>
+            </a:prstGeom>
+            <a:noFill/>
+          </p:spPr>
+          <p:txBody>
+            <a:bodyPr wrap="none" rtlCol="0">
+              <a:spAutoFit/>
+            </a:bodyPr>
+            <a:lstStyle/>
+            <a:p>
+              <a:pPr algn="ctr"/>
+              <a:r>
+                <a:rPr lang="en-US" dirty="0">
+                  <a:solidFill>
+                    <a:schemeClr val="bg1"/>
+                  </a:solidFill>
+                </a:rPr>
+                <a:t>Example Check</a:t>
+              </a:r>
+            </a:p>
+          </p:txBody>
+        </p:sp>
         <p:grpSp>
           <p:nvGrpSpPr>
-            <p:cNvPr id="9" name="Group 8">
+            <p:cNvPr id="14" name="Group 13">
               <a:extLst>
                 <a:ext uri="{FF2B5EF4-FFF2-40B4-BE49-F238E27FC236}">
-                  <a16:creationId xmlns:a16="http://schemas.microsoft.com/office/drawing/2014/main" id="{2A1C59D2-29A0-E23B-6D04-B452ACCF75E5}"/>
+                  <a16:creationId xmlns:a16="http://schemas.microsoft.com/office/drawing/2014/main" id="{C287D273-2D1F-5818-E2FE-F9100DD3C98E}"/>
                 </a:ext>
               </a:extLst>
             </p:cNvPr>
@@ -7745,10 +7783,10 @@
           </p:nvGrpSpPr>
           <p:grpSpPr>
             <a:xfrm>
-              <a:off x="2039816" y="2568286"/>
-              <a:ext cx="5698208" cy="3000881"/>
-              <a:chOff x="1687019" y="2094031"/>
-              <a:chExt cx="6705600" cy="3531408"/>
+              <a:off x="1583085" y="2377442"/>
+              <a:ext cx="7387943" cy="3157858"/>
+              <a:chOff x="3014728" y="2989374"/>
+              <a:chExt cx="5956300" cy="2545925"/>
             </a:xfrm>
           </p:grpSpPr>
           <p:pic>
@@ -7773,8 +7811,8 @@
             </p:blipFill>
             <p:spPr>
               <a:xfrm>
-                <a:off x="1715721" y="4355439"/>
-                <a:ext cx="6591300" cy="1270000"/>
+                <a:off x="3076952" y="4399638"/>
+                <a:ext cx="5894076" cy="1135661"/>
               </a:xfrm>
               <a:prstGeom prst="rect">
                 <a:avLst/>
@@ -7783,10 +7821,10 @@
           </p:pic>
           <p:pic>
             <p:nvPicPr>
-              <p:cNvPr id="6" name="Picture 5">
+              <p:cNvPr id="11" name="Picture 10">
                 <a:extLst>
                   <a:ext uri="{FF2B5EF4-FFF2-40B4-BE49-F238E27FC236}">
-                    <a16:creationId xmlns:a16="http://schemas.microsoft.com/office/drawing/2014/main" id="{9386B1BA-E0EC-23E8-B604-0DA417EC1B03}"/>
+                    <a16:creationId xmlns:a16="http://schemas.microsoft.com/office/drawing/2014/main" id="{ABBF342E-5AE0-D331-1F4A-53C4A4FBEB1D}"/>
                   </a:ext>
                 </a:extLst>
               </p:cNvPr>
@@ -7803,8 +7841,8 @@
             </p:blipFill>
             <p:spPr>
               <a:xfrm>
-                <a:off x="1687019" y="2094031"/>
-                <a:ext cx="6705600" cy="2171701"/>
+                <a:off x="3014728" y="2989374"/>
+                <a:ext cx="5956300" cy="1270000"/>
               </a:xfrm>
               <a:prstGeom prst="rect">
                 <a:avLst/>
@@ -7812,46 +7850,6 @@
             </p:spPr>
           </p:pic>
         </p:grpSp>
-        <p:sp>
-          <p:nvSpPr>
-            <p:cNvPr id="10" name="TextBox 9">
-              <a:extLst>
-                <a:ext uri="{FF2B5EF4-FFF2-40B4-BE49-F238E27FC236}">
-                  <a16:creationId xmlns:a16="http://schemas.microsoft.com/office/drawing/2014/main" id="{951E1D4C-C443-76A6-47F2-F4E497381A31}"/>
-                </a:ext>
-              </a:extLst>
-            </p:cNvPr>
-            <p:cNvSpPr txBox="1"/>
-            <p:nvPr/>
-          </p:nvSpPr>
-          <p:spPr>
-            <a:xfrm>
-              <a:off x="121909" y="3814566"/>
-              <a:ext cx="1735026" cy="369332"/>
-            </a:xfrm>
-            <a:prstGeom prst="rect">
-              <a:avLst/>
-            </a:prstGeom>
-            <a:noFill/>
-          </p:spPr>
-          <p:txBody>
-            <a:bodyPr wrap="none" rtlCol="0">
-              <a:spAutoFit/>
-            </a:bodyPr>
-            <a:lstStyle/>
-            <a:p>
-              <a:pPr algn="ctr"/>
-              <a:r>
-                <a:rPr lang="en-US" dirty="0">
-                  <a:solidFill>
-                    <a:schemeClr val="bg1"/>
-                  </a:solidFill>
-                </a:rPr>
-                <a:t>Example Check</a:t>
-              </a:r>
-            </a:p>
-          </p:txBody>
-        </p:sp>
       </p:grpSp>
     </p:spTree>
     <p:extLst>
@@ -9107,10 +9105,10 @@
       </p:sp>
       <p:grpSp>
         <p:nvGrpSpPr>
-          <p:cNvPr id="14" name="Group 13">
+          <p:cNvPr id="16" name="Group 15">
             <a:extLst>
               <a:ext uri="{FF2B5EF4-FFF2-40B4-BE49-F238E27FC236}">
-                <a16:creationId xmlns:a16="http://schemas.microsoft.com/office/drawing/2014/main" id="{EDFD874D-1538-B509-3D69-0981A4627FC2}"/>
+                <a16:creationId xmlns:a16="http://schemas.microsoft.com/office/drawing/2014/main" id="{1BA4F825-489C-82EA-9D87-7F0AF37FCFC1}"/>
               </a:ext>
             </a:extLst>
           </p:cNvPr>
@@ -9119,18 +9117,48 @@
         </p:nvGrpSpPr>
         <p:grpSpPr>
           <a:xfrm>
-            <a:off x="954766" y="2377441"/>
-            <a:ext cx="8170105" cy="3189673"/>
-            <a:chOff x="1033052" y="2312502"/>
-            <a:chExt cx="8170105" cy="3189673"/>
+            <a:off x="128541" y="2377441"/>
+            <a:ext cx="9822555" cy="3090242"/>
+            <a:chOff x="240726" y="2372836"/>
+            <a:chExt cx="9822555" cy="3090242"/>
           </a:xfrm>
         </p:grpSpPr>
+        <p:pic>
+          <p:nvPicPr>
+            <p:cNvPr id="6" name="Picture 5">
+              <a:extLst>
+                <a:ext uri="{FF2B5EF4-FFF2-40B4-BE49-F238E27FC236}">
+                  <a16:creationId xmlns:a16="http://schemas.microsoft.com/office/drawing/2014/main" id="{339475B0-128A-1D6A-B762-E7B564115DF5}"/>
+                </a:ext>
+              </a:extLst>
+            </p:cNvPr>
+            <p:cNvPicPr>
+              <a:picLocks noChangeAspect="1"/>
+            </p:cNvPicPr>
+            <p:nvPr/>
+          </p:nvPicPr>
+          <p:blipFill>
+            <a:blip r:embed="rId2"/>
+            <a:stretch>
+              <a:fillRect/>
+            </a:stretch>
+          </p:blipFill>
+          <p:spPr>
+            <a:xfrm>
+              <a:off x="2066512" y="2372836"/>
+              <a:ext cx="7996769" cy="1237139"/>
+            </a:xfrm>
+            <a:prstGeom prst="rect">
+              <a:avLst/>
+            </a:prstGeom>
+          </p:spPr>
+        </p:pic>
         <p:sp>
           <p:nvSpPr>
-            <p:cNvPr id="10" name="TextBox 9">
+            <p:cNvPr id="8" name="TextBox 7">
               <a:extLst>
                 <a:ext uri="{FF2B5EF4-FFF2-40B4-BE49-F238E27FC236}">
-                  <a16:creationId xmlns:a16="http://schemas.microsoft.com/office/drawing/2014/main" id="{751AAF05-7E7E-1CB8-82AB-DBDB1F3E2993}"/>
+                  <a16:creationId xmlns:a16="http://schemas.microsoft.com/office/drawing/2014/main" id="{491CACAA-8F5D-DCE9-ECCC-B31D41E1D4C0}"/>
                 </a:ext>
               </a:extLst>
             </p:cNvPr>
@@ -9139,7 +9167,7 @@
           </p:nvSpPr>
           <p:spPr>
             <a:xfrm>
-              <a:off x="1033052" y="3688914"/>
+              <a:off x="240726" y="3843377"/>
               <a:ext cx="1825786" cy="388652"/>
             </a:xfrm>
             <a:prstGeom prst="rect">
@@ -9165,89 +9193,36 @@
             </a:p>
           </p:txBody>
         </p:sp>
-        <p:grpSp>
-          <p:nvGrpSpPr>
-            <p:cNvPr id="12" name="Group 11">
+        <p:pic>
+          <p:nvPicPr>
+            <p:cNvPr id="15" name="Picture 14">
               <a:extLst>
                 <a:ext uri="{FF2B5EF4-FFF2-40B4-BE49-F238E27FC236}">
-                  <a16:creationId xmlns:a16="http://schemas.microsoft.com/office/drawing/2014/main" id="{C7A53FBF-594A-5D9D-AC5D-272BF13DDEC0}"/>
+                  <a16:creationId xmlns:a16="http://schemas.microsoft.com/office/drawing/2014/main" id="{787B8874-105D-22A1-93C3-CF03B2BC5B26}"/>
                 </a:ext>
               </a:extLst>
             </p:cNvPr>
-            <p:cNvGrpSpPr>
-              <a:grpSpLocks noChangeAspect="1"/>
-            </p:cNvGrpSpPr>
+            <p:cNvPicPr>
+              <a:picLocks noChangeAspect="1"/>
+            </p:cNvPicPr>
             <p:nvPr/>
-          </p:nvGrpSpPr>
-          <p:grpSpPr>
+          </p:nvPicPr>
+          <p:blipFill>
+            <a:blip r:embed="rId3"/>
+            <a:stretch>
+              <a:fillRect/>
+            </a:stretch>
+          </p:blipFill>
+          <p:spPr>
             <a:xfrm>
-              <a:off x="2858837" y="2312502"/>
-              <a:ext cx="6344320" cy="3189673"/>
-              <a:chOff x="1153619" y="1647182"/>
-              <a:chExt cx="7772400" cy="3907656"/>
+              <a:off x="2066512" y="3773978"/>
+              <a:ext cx="6616700" cy="1689100"/>
             </a:xfrm>
-          </p:grpSpPr>
-          <p:pic>
-            <p:nvPicPr>
-              <p:cNvPr id="11" name="Picture 10">
-                <a:extLst>
-                  <a:ext uri="{FF2B5EF4-FFF2-40B4-BE49-F238E27FC236}">
-                    <a16:creationId xmlns:a16="http://schemas.microsoft.com/office/drawing/2014/main" id="{CB75FE47-B2C3-01E5-48DF-1AF858C41578}"/>
-                  </a:ext>
-                </a:extLst>
-              </p:cNvPr>
-              <p:cNvPicPr>
-                <a:picLocks noChangeAspect="1"/>
-              </p:cNvPicPr>
-              <p:nvPr/>
-            </p:nvPicPr>
-            <p:blipFill>
-              <a:blip r:embed="rId2"/>
-              <a:stretch>
-                <a:fillRect/>
-              </a:stretch>
-            </p:blipFill>
-            <p:spPr>
-              <a:xfrm>
-                <a:off x="1198031" y="3840338"/>
-                <a:ext cx="6616700" cy="1714500"/>
-              </a:xfrm>
-              <a:prstGeom prst="rect">
-                <a:avLst/>
-              </a:prstGeom>
-            </p:spPr>
-          </p:pic>
-          <p:pic>
-            <p:nvPicPr>
-              <p:cNvPr id="5" name="Picture 4">
-                <a:extLst>
-                  <a:ext uri="{FF2B5EF4-FFF2-40B4-BE49-F238E27FC236}">
-                    <a16:creationId xmlns:a16="http://schemas.microsoft.com/office/drawing/2014/main" id="{D15165CA-CBAD-0626-30C7-4B07B9487877}"/>
-                  </a:ext>
-                </a:extLst>
-              </p:cNvPr>
-              <p:cNvPicPr>
-                <a:picLocks noChangeAspect="1"/>
-              </p:cNvPicPr>
-              <p:nvPr/>
-            </p:nvPicPr>
-            <p:blipFill>
-              <a:blip r:embed="rId3"/>
-              <a:stretch>
-                <a:fillRect/>
-              </a:stretch>
-            </p:blipFill>
-            <p:spPr>
-              <a:xfrm>
-                <a:off x="1153619" y="1647182"/>
-                <a:ext cx="7772400" cy="2150852"/>
-              </a:xfrm>
-              <a:prstGeom prst="rect">
-                <a:avLst/>
-              </a:prstGeom>
-            </p:spPr>
-          </p:pic>
-        </p:grpSp>
+            <a:prstGeom prst="rect">
+              <a:avLst/>
+            </a:prstGeom>
+          </p:spPr>
+        </p:pic>
       </p:grpSp>
     </p:spTree>
     <p:extLst>

</xml_diff>